<commit_message>
fix(fixtures): use a single PowerPoint animation timing root
</commit_message>
<xml_diff>
--- a/apps/docs/static/samples/rendering-checks.pptx
+++ b/apps/docs/static/samples/rendering-checks.pptx
@@ -3070,30 +3070,56 @@
   <p:timing>
     <p:tnLst>
       <p:par>
-        <p:cTn id="1" nodeType="clickEffect">
+        <p:cTn id="100" dur="indefinite" restart="never" nodeType="tmRoot">
           <p:childTnLst>
-            <p:animEffect transition="in" filter="fade">
-              <p:cBhvr>
-                <p:cTn id="11" dur="500"/>
-                <p:tgtEl>
-                  <p:spTgt spid="4"/>
-                </p:tgtEl>
-              </p:cBhvr>
-            </p:animEffect>
-          </p:childTnLst>
-        </p:cTn>
-      </p:par>
-      <p:par>
-        <p:cTn id="2" nodeType="clickEffect">
-          <p:childTnLst>
-            <p:animEffect transition="in" filter="wipe(left)">
-              <p:cBhvr>
-                <p:cTn id="12" dur="500"/>
-                <p:tgtEl>
-                  <p:spTgt spid="5"/>
-                </p:tgtEl>
-              </p:cBhvr>
-            </p:animEffect>
+            <p:seq concurrent="1" nextAc="seek">
+              <p:cTn id="101" dur="indefinite" nodeType="mainSeq">
+                <p:childTnLst>
+                  <p:par>
+                    <p:cTn id="1" nodeType="clickEffect">
+                      <p:childTnLst>
+                        <p:animEffect transition="in" filter="fade">
+                          <p:cBhvr>
+                            <p:cTn id="11" dur="500"/>
+                            <p:tgtEl>
+                              <p:spTgt spid="4"/>
+                            </p:tgtEl>
+                          </p:cBhvr>
+                        </p:animEffect>
+                      </p:childTnLst>
+                    </p:cTn>
+                  </p:par>
+                  <p:par>
+                    <p:cTn id="2" nodeType="clickEffect">
+                      <p:childTnLst>
+                        <p:animEffect transition="in" filter="wipe(left)">
+                          <p:cBhvr>
+                            <p:cTn id="12" dur="500"/>
+                            <p:tgtEl>
+                              <p:spTgt spid="5"/>
+                            </p:tgtEl>
+                          </p:cBhvr>
+                        </p:animEffect>
+                      </p:childTnLst>
+                    </p:cTn>
+                  </p:par>
+                </p:childTnLst>
+              </p:cTn>
+              <p:prevCondLst>
+                <p:cond evt="onPrev" delay="0">
+                  <p:tgtEl>
+                    <p:sldTgt/>
+                  </p:tgtEl>
+                </p:cond>
+              </p:prevCondLst>
+              <p:nextCondLst>
+                <p:cond evt="onNext" delay="0">
+                  <p:tgtEl>
+                    <p:sldTgt/>
+                  </p:tgtEl>
+                </p:cond>
+              </p:nextCondLst>
+            </p:seq>
           </p:childTnLst>
         </p:cTn>
       </p:par>

</xml_diff>

<commit_message>
fix(docs): replace the blank video demo with visible motion
</commit_message>
<xml_diff>
--- a/apps/docs/static/samples/rendering-checks.pptx
+++ b/apps/docs/static/samples/rendering-checks.pptx
@@ -2897,8 +2897,8 @@
         </p:blipFill>
         <p:spPr>
           <a:xfrm>
-            <a:off x="914400" y="1828800"/>
-            <a:ext cx="10058400" cy="4389120"/>
+            <a:off x="2194560" y="1828800"/>
+            <a:ext cx="7799832" cy="4389120"/>
           </a:xfrm>
           <a:prstGeom prst="rect">
             <a:avLst/>

</xml_diff>